<commit_message>
Switch middle-school lesson materials to individual work
Deck and worksheet now assume each student makes their own song on a
no-signup AI music site, with a Padlet backup library, and gives
partner feedback instead of group roles.

Co-Authored-By: Claude Opus 5.5 <noreply@anthropic.com>
Claude-Session: https://claude.ai/code/session_01LJssAQrTFX97gi8zMMX3x4
</commit_message>
<xml_diff>
--- a/평택여고_2026-10-21/PPT_중학생용_휴대폰실습.pptx
+++ b/평택여고_2026-10-21/PPT_중학생용_휴대폰실습.pptx
@@ -126,7 +126,7 @@
   <p:extLst>
     <p:ext uri="{521415D9-36F7-43E2-AB2F-B90AF26B5E84}">
       <p14:sectionLst xmlns:p14="http://schemas.microsoft.com/office/powerpoint/2010/main">
-        <p14:section name="도입" id="{13753ab8-bd52-ac55-b1f7-774934dc6665}">
+        <p14:section name="도입" id="{949a229b-1152-3039-04ac-27330c0e1f5f}">
           <p14:sldIdLst>
             <p14:sldId id="256"/>
             <p14:sldId id="257"/>
@@ -135,7 +135,7 @@
             <p14:sldId id="260"/>
           </p14:sldIdLst>
         </p14:section>
-        <p14:section name="1차시 음악" id="{606d1f21-e733-1aee-e1fb-b10d8383f7b5}">
+        <p14:section name="1차시 음악" id="{bf433ff5-0394-7a84-3037-38150dbe2fcb}">
           <p14:sldIdLst>
             <p14:sldId id="261"/>
             <p14:sldId id="262"/>
@@ -146,7 +146,7 @@
             <p14:sldId id="267"/>
           </p14:sldIdLst>
         </p14:section>
-        <p14:section name="2차시 영상" id="{07e11a70-792e-ea1b-2472-09d805b7df3d}">
+        <p14:section name="2차시 영상" id="{32c562dc-222f-583c-9259-88e5f1db6568}">
           <p14:sldIdLst>
             <p14:sldId id="268"/>
             <p14:sldId id="269"/>
@@ -156,7 +156,7 @@
             <p14:sldId id="273"/>
           </p14:sldIdLst>
         </p14:section>
-        <p14:section name="마무리" id="{2c2c19b9-23b7-3e79-db77-ace7c9e8fff3}">
+        <p14:section name="마무리" id="{a5bb1c6f-6532-9f4f-253c-7b711b681575}">
           <p14:sldIdLst>
             <p14:sldId id="274"/>
             <p14:sldId id="275"/>
@@ -566,7 +566,7 @@
           <a:p>
             <a:r>
               <a:rPr lang="en-US" dirty="0"/>
-              <a:t>인사 및 강사 소개. 오늘은 휴대폰 하나로 모둠별 노래를 AI로 만들고, 그 노래로 뮤직비디오를 편집합니다. 시작 전에 강사가 미리 만든 1분짜리 샘플 뮤직비디오를 보여 주면 동기 유발에 좋습니다.</a:t>
+              <a:t>인사 및 강사 소개. 오늘은 각자 휴대폰으로 나만의 노래를 AI로 만들고, 그 노래로 나만의 뮤직비디오를 편집합니다. 시작 전에 강사가 미리 만든 1분짜리 샘플 뮤직비디오를 보여 주면 동기 유발에 좋습니다.</a:t>
             </a:r>
             <a:endParaRPr lang="en-US" dirty="0"/>
           </a:p>
@@ -654,7 +654,7 @@
           <a:p>
             <a:r>
               <a:rPr lang="en-US" dirty="0"/>
-              <a:t>Suno 커스텀 모드의 가사 칸에 태그와 함께 그대로 입력합니다. 활동지 STEP 3 표에 Verse 4줄, Chorus 4줄을 쓰게 합니다.</a:t>
+              <a:t>가사 입력 칸이 있는 사이트는 태그와 함께 그대로 넣습니다. 가사 칸이 없거나 보컬이 안 되는 사이트라면 가사를 영상 자막으로 활용합니다.</a:t>
             </a:r>
             <a:endParaRPr lang="en-US" dirty="0"/>
           </a:p>
@@ -742,7 +742,7 @@
           <a:p>
             <a:r>
               <a:rPr lang="en-US" dirty="0"/>
-              <a:t>15분 활동. 프롬프트와 가사가 먼저 끝난 모둠부터 강사가 순서대로 생성을 시작하면 시간이 절약됩니다. 생성을 기다리는 동안 STEP 4 스토리보드를 마무리하게 합니다.</a:t>
+              <a:t>12분 개인 활동. 주제가 안 떠오르는 학생에게는 '좋아하는 계절'이나 '나의 꿈'을 권합니다. 다 쓴 학생부터 바로 다음 단계(AI 노래 만들기)로 넘어가게 해 속도 차이를 흡수합니다.</a:t>
             </a:r>
             <a:endParaRPr lang="en-US" dirty="0"/>
           </a:p>
@@ -830,7 +830,7 @@
           <a:p>
             <a:r>
               <a:rPr lang="en-US" dirty="0"/>
-              <a:t>모둠당 약 2분. 6모둠이면 15분 내외. 크레딧이 부족하면 두 번째 강사 계정으로 바꿉니다. 1차시 끝에 패들렛 QR을 안내하고, 쉬는 시간에 각 모둠이 고른 곡을 내려받아 패들렛에 올립니다.</a:t>
+              <a:t>15분 개인 실습. 30명이 같은 와이파이로 동시에 접속하면 사이트가 느려지거나 횟수 제한에 걸릴 수 있습니다. 학생 데이터(LTE) 사용도 허용하고, 5분 안에 안 되는 학생은 바로 패들렛 예비 음원으로 넘어가게 하세요. 끝나기 3분 전 '다운로드 확인' 시간을 줍니다. 강사는 빔 화면에 Gemini 등으로 1곡을 시연해도 좋습니다.</a:t>
             </a:r>
             <a:endParaRPr lang="en-US" dirty="0"/>
           </a:p>
@@ -918,7 +918,7 @@
           <a:p>
             <a:r>
               <a:rPr lang="en-US" dirty="0"/>
-              <a:t>2차시 시작. 모든 모둠이 노래 파일을 휴대폰에 저장했는지 먼저 확인합니다.</a:t>
+              <a:t>2차시 시작. 모든 학생이 노래 파일을 휴대폰에 저장했는지 먼저 확인합니다.</a:t>
             </a:r>
             <a:endParaRPr lang="en-US" dirty="0"/>
           </a:p>
@@ -1006,7 +1006,7 @@
           <a:p>
             <a:r>
               <a:rPr lang="en-US" dirty="0"/>
-              <a:t>메뉴 이름은 휴대폰·앱 버전에 따라 조금씩 다릅니다. 수업 전에 아이폰과 갤럭시에서 '패들렛 다운로드 → CapCut 불러오기'를 직접 리허설해 두세요. 받기 어려운 학생은 모둠 친구의 휴대폰 한 대로 편집해도 됩니다.</a:t>
+              <a:t>메뉴 이름은 휴대폰·앱 버전에 따라 조금씩 다릅니다. 수업 전에 아이폰과 갤럭시에서 'AI 사이트 다운로드 → CapCut 불러오기'를 직접 리허설해 두세요. 파일이 없는 학생은 패들렛 예비 음원을 받게 합니다.</a:t>
             </a:r>
             <a:endParaRPr lang="en-US" dirty="0"/>
           </a:p>
@@ -1094,7 +1094,7 @@
           <a:p>
             <a:r>
               <a:rPr lang="en-US" dirty="0"/>
-              <a:t>촬영 범위(교실, 복도 등)를 미리 정해 주세요. 얼굴 대신 손·뒷모습·사물을 찍으면 개인정보 걱정이 줄고 오히려 감성적인 영상이 나옵니다. 모둠이 AI 이미지 프롬프트를 냈다면 강사가 만든 이미지를 패들렛에서 받아 함께 써도 됩니다.</a:t>
+              <a:t>촬영 범위(교실, 복도 등)를 미리 정해 주세요. 얼굴 대신 손·뒷모습·사물을 찍으면 개인정보 걱정이 줄고 오히려 감성적인 영상이 나옵니다. 시간이 부족한 학생은 사진 3~4장만으로도 충분합니다.</a:t>
             </a:r>
             <a:endParaRPr lang="en-US" dirty="0"/>
           </a:p>
@@ -1446,7 +1446,7 @@
           <a:p>
             <a:r>
               <a:rPr lang="en-US" dirty="0"/>
-              <a:t>패들렛에 올라온 작품을 빔 화면에서 재생합니다. 발표자가 10초 정도 작품을 소개하고, 다른 모둠은 활동지 피드백 표에 칭찬 1 + 제안 1을 적습니다.</a:t>
+              <a:t>먼저 짝과 휴대폰을 바꿔 서로의 작품을 보고 활동지에 칭찬 1 + 제안 1을 적습니다(5분). 그다음 패들렛에 올라온 작품 중 3~4편을 골라(지원자 우선) 빔 화면에서 함께 감상합니다.</a:t>
             </a:r>
             <a:endParaRPr lang="en-US" dirty="0"/>
           </a:p>
@@ -1534,7 +1534,7 @@
           <a:p>
             <a:r>
               <a:rPr lang="en-US" dirty="0"/>
-              <a:t>1차시 50분, 쉬는 시간 10분, 2차시 50분. 쉬는 시간에 강사는 모둠별 노래를 내려받아 패들렛에 올리고, 학생은 휴대폰에 저장합니다.</a:t>
+              <a:t>1차시 50분, 쉬는 시간 10분, 2차시 50분. 쉬는 시간에는 노래를 못 받은 학생이 예비 음원(패들렛)을 받도록 돕습니다.</a:t>
             </a:r>
             <a:endParaRPr lang="en-US" dirty="0"/>
           </a:p>
@@ -1710,7 +1710,7 @@
           <a:p>
             <a:r>
               <a:rPr lang="en-US" dirty="0"/>
-              <a:t>Suno 등 AI 음악 서비스는 13세 미만 이용 불가, 13~17세는 보호자 동의가 필요합니다. 그래서 학생 계정은 만들지 않고 강사 계정으로 생성합니다. CapCut은 로그인 없이 기본 편집과 내보내기가 가능하지만, 앱 버전에 따라 다를 수 있으니 사전에 확인하세요.</a:t>
+              <a:t>Suno 등 AI 음악 서비스는 13세 미만 이용 불가, 13~17세는 보호자 동의가 필요합니다. 그래서 학생은 가입 없이 쓰는 무료 사이트만 씁니다(강사가 수업 전 1곳을 골라 QR로 안내). CapCut은 로그인 없이 기본 편집과 내보내기가 가능하지만, 앱 버전에 따라 다를 수 있으니 사전에 확인하세요.</a:t>
             </a:r>
             <a:endParaRPr lang="en-US" dirty="0"/>
           </a:p>
@@ -1886,7 +1886,7 @@
           <a:p>
             <a:r>
               <a:rPr lang="en-US" dirty="0"/>
-              <a:t>모둠 구성 후 역할을 정하고 활동지 첫 표에 적게 합니다. 역할이 있어야 휴대폰 한 대로도 모두가 참여합니다.</a:t>
+              <a:t>개인 활동으로 진행합니다. 활동지는 한 명당 한 장. 옆자리 친구와 서로 도와주는 것은 허용해 막힘을 줄입니다.</a:t>
             </a:r>
             <a:endParaRPr lang="en-US" dirty="0"/>
           </a:p>
@@ -2062,7 +2062,7 @@
           <a:p>
             <a:r>
               <a:rPr lang="en-US" dirty="0"/>
-              <a:t>운영 메모: Suno 무료 계정은 하루 50크레딧, 생성 1회(2곡)에 10크레딧이라 6모둠이면 계정 2개가 필요합니다. 2026년 9월부터 무료 계정 다운로드가 제한되었다는 보도가 있으니, 다운로드가 막히면 미리 만들어 둔 예비곡을 사용하세요. 수업 전 suno.com/pricing에서 최신 정책을 확인하세요.</a:t>
+              <a:t>운영 메모: Suno 무료는 다운로드가 계정당 평생 7회로 제한되고 Gemini 음악은 만 18세 이상이라, 학생 개인 실습에는 '가입 없이 MP3를 받을 수 있는 무료 사이트'를 씁니다. 후보(2026년 10월 검색 기준, 모두 소규모 업체라 직접 확인 필요): onlymusic.ai, songai.io, boppy.me, aimusicgen.ai. 수업 전 휴대폰으로 ① 가입 없이 생성되는지 ② 한국어 가사·보컬이 되는지 ③ MP3 다운로드가 되는지 ④ 광고·이용 연령·이용약관 ⑤ 학교 와이파이에서 30명이 동시에 써도 막히지 않는지 확인하고 1곳을 QR로 안내하세요. 보컬이 안 되는 사이트면 가사는 영상 자막으로 씁니다. 실패에 대비해 예비 음원 10~15곡을 패들렛에 올려 두세요.</a:t>
             </a:r>
             <a:endParaRPr lang="en-US" dirty="0"/>
           </a:p>
@@ -3115,7 +3115,7 @@
                   <a:schemeClr val="bg1"/>
                 </a:solidFill>
               </a:rPr>
-              <a:t>우리 모둠 뮤직비디오</a:t>
+              <a:t>나만의 뮤직비디오</a:t>
             </a:r>
             <a:endParaRPr lang="en-US" sz="4400" dirty="0"/>
           </a:p>
@@ -4081,7 +4081,7 @@
                   <a:schemeClr val="tx1"/>
                 </a:solidFill>
               </a:rPr>
-              <a:t>모둠 활동 · 활동지 STEP 1~4</a:t>
+              <a:t>개인 활동 · 활동지 STEP 1~3</a:t>
             </a:r>
             <a:endParaRPr lang="en-US" sz="3200" dirty="0"/>
           </a:p>
@@ -4531,7 +4531,7 @@
                   <a:schemeClr val="tx2"/>
                 </a:solidFill>
               </a:rPr>
-              <a:t>[Verse] 4줄 + [Chorus] 4줄, 모두 8줄</a:t>
+              <a:t>[Verse] + [Chorus] 4~8줄 (영상 자막으로도 써요)</a:t>
             </a:r>
             <a:endParaRPr lang="en-US" sz="1400" dirty="0"/>
           </a:p>
@@ -4539,271 +4539,49 @@
       </p:sp>
       <p:sp>
         <p:nvSpPr>
-          <p:cNvPr id="18" name="step card 4"/>
-          <p:cNvSpPr/>
-          <p:nvPr/>
-        </p:nvSpPr>
-        <p:spPr>
-          <a:xfrm>
-            <a:off x="548640" y="4754880"/>
-            <a:ext cx="8503920" cy="914400"/>
+          <p:cNvPr id="18" name="lyrics tip"/>
+          <p:cNvSpPr/>
+          <p:nvPr/>
+        </p:nvSpPr>
+        <p:spPr>
+          <a:xfrm>
+            <a:off x="548640" y="4892040"/>
+            <a:ext cx="8503920" cy="1005840"/>
           </a:xfrm>
           <a:prstGeom prst="roundRect">
             <a:avLst>
-              <a:gd name="adj" fmla="val 12000"/>
+              <a:gd name="adj" fmla="val 10909"/>
             </a:avLst>
           </a:prstGeom>
           <a:solidFill>
-            <a:schemeClr val="bg2"/>
-          </a:solidFill>
-          <a:ln/>
-        </p:spPr>
-      </p:sp>
-      <p:sp>
-        <p:nvSpPr>
-          <p:cNvPr id="19" name="step 4"/>
-          <p:cNvSpPr/>
-          <p:nvPr/>
-        </p:nvSpPr>
-        <p:spPr>
-          <a:xfrm>
-            <a:off x="777240" y="4910328"/>
-            <a:ext cx="603504" cy="603504"/>
+            <a:schemeClr val="tx1"/>
+          </a:solidFill>
+          <a:ln/>
+        </p:spPr>
+      </p:sp>
+      <p:sp>
+        <p:nvSpPr>
+          <p:cNvPr id="19" name="tip circle"/>
+          <p:cNvSpPr/>
+          <p:nvPr/>
+        </p:nvSpPr>
+        <p:spPr>
+          <a:xfrm>
+            <a:off x="777240" y="5047488"/>
+            <a:ext cx="685800" cy="685800"/>
           </a:xfrm>
           <a:prstGeom prst="ellipse">
             <a:avLst/>
           </a:prstGeom>
           <a:solidFill>
-            <a:schemeClr val="accent1"/>
-          </a:solidFill>
-          <a:ln/>
-        </p:spPr>
-      </p:sp>
-      <p:sp>
-        <p:nvSpPr>
-          <p:cNvPr id="20" name="Text 18"/>
-          <p:cNvSpPr txBox="1"/>
-          <p:nvPr/>
-        </p:nvSpPr>
-        <p:spPr>
-          <a:xfrm>
-            <a:off x="777240" y="4910328"/>
-            <a:ext cx="603504" cy="603504"/>
-          </a:xfrm>
-          <a:prstGeom prst="rect">
-            <a:avLst/>
-          </a:prstGeom>
-          <a:noFill/>
-          <a:ln/>
-        </p:spPr>
-        <p:txBody>
-          <a:bodyPr wrap="square" lIns="0" tIns="0" rIns="0" bIns="0" rtlCol="0" anchor="ctr"/>
-          <a:lstStyle/>
-          <a:p>
-            <a:pPr algn="ctr" indent="0" marL="0">
-              <a:buNone/>
-            </a:pPr>
-            <a:r>
-              <a:rPr lang="en-US" sz="2000" b="1" dirty="0">
-                <a:solidFill>
-                  <a:schemeClr val="bg1"/>
-                </a:solidFill>
-              </a:rPr>
-              <a:t>4</a:t>
-            </a:r>
-            <a:endParaRPr lang="en-US" sz="2000" dirty="0"/>
-          </a:p>
-        </p:txBody>
-      </p:sp>
-      <p:sp>
-        <p:nvSpPr>
-          <p:cNvPr id="21" name="Text 19"/>
-          <p:cNvSpPr txBox="1"/>
-          <p:nvPr/>
-        </p:nvSpPr>
-        <p:spPr>
-          <a:xfrm>
-            <a:off x="1600200" y="4754880"/>
-            <a:ext cx="2377440" cy="914400"/>
-          </a:xfrm>
-          <a:prstGeom prst="rect">
-            <a:avLst/>
-          </a:prstGeom>
-          <a:noFill/>
-          <a:ln/>
-        </p:spPr>
-        <p:txBody>
-          <a:bodyPr wrap="square" lIns="0" tIns="0" rIns="0" bIns="0" rtlCol="0" anchor="ctr"/>
-          <a:lstStyle/>
-          <a:p>
-            <a:pPr indent="0" marL="0">
-              <a:buNone/>
-            </a:pPr>
-            <a:r>
-              <a:rPr lang="en-US" sz="1800" b="1" dirty="0">
-                <a:solidFill>
-                  <a:schemeClr val="tx1"/>
-                </a:solidFill>
-              </a:rPr>
-              <a:t>4컷 스토리보드</a:t>
-            </a:r>
-            <a:endParaRPr lang="en-US" sz="1800" dirty="0"/>
-          </a:p>
-        </p:txBody>
-      </p:sp>
-      <p:sp>
-        <p:nvSpPr>
-          <p:cNvPr id="22" name="Text 20"/>
-          <p:cNvSpPr txBox="1"/>
-          <p:nvPr/>
-        </p:nvSpPr>
-        <p:spPr>
-          <a:xfrm>
-            <a:off x="3977640" y="4754880"/>
-            <a:ext cx="4892040" cy="914400"/>
-          </a:xfrm>
-          <a:prstGeom prst="rect">
-            <a:avLst/>
-          </a:prstGeom>
-          <a:noFill/>
-          <a:ln/>
-        </p:spPr>
-        <p:txBody>
-          <a:bodyPr wrap="square" lIns="0" tIns="0" rIns="0" bIns="0" rtlCol="0" anchor="ctr"/>
-          <a:lstStyle/>
-          <a:p>
-            <a:pPr indent="0" marL="0">
-              <a:buNone/>
-            </a:pPr>
-            <a:r>
-              <a:rPr lang="en-US" sz="1400" dirty="0">
-                <a:solidFill>
-                  <a:schemeClr val="tx2"/>
-                </a:solidFill>
-              </a:rPr>
-              <a:t>노래 구간마다 찍을 장면을 그림과 글로 설계</a:t>
-            </a:r>
-            <a:endParaRPr lang="en-US" sz="1400" dirty="0"/>
-          </a:p>
-        </p:txBody>
-      </p:sp>
-      <p:sp>
-        <p:nvSpPr>
-          <p:cNvPr id="23" name="timer"/>
-          <p:cNvSpPr/>
-          <p:nvPr/>
-        </p:nvSpPr>
-        <p:spPr>
-          <a:xfrm>
-            <a:off x="9601200" y="1463040"/>
-            <a:ext cx="2011680" cy="1005840"/>
-          </a:xfrm>
-          <a:prstGeom prst="roundRect">
-            <a:avLst>
-              <a:gd name="adj" fmla="val 12727"/>
-            </a:avLst>
-          </a:prstGeom>
-          <a:solidFill>
-            <a:schemeClr val="tx1"/>
-          </a:solidFill>
-          <a:ln/>
-        </p:spPr>
-      </p:sp>
-      <p:sp>
-        <p:nvSpPr>
-          <p:cNvPr id="24" name="Text 22"/>
-          <p:cNvSpPr txBox="1"/>
-          <p:nvPr/>
-        </p:nvSpPr>
-        <p:spPr>
-          <a:xfrm>
-            <a:off x="9601200" y="1572768"/>
-            <a:ext cx="2011680" cy="274320"/>
-          </a:xfrm>
-          <a:prstGeom prst="rect">
-            <a:avLst/>
-          </a:prstGeom>
-          <a:noFill/>
-          <a:ln/>
-        </p:spPr>
-        <p:txBody>
-          <a:bodyPr wrap="square" lIns="0" tIns="0" rIns="0" bIns="0" rtlCol="0" anchor="t"/>
-          <a:lstStyle/>
-          <a:p>
-            <a:pPr algn="ctr" indent="0" marL="0">
-              <a:buNone/>
-            </a:pPr>
-            <a:r>
-              <a:rPr lang="en-US" sz="1200" dirty="0">
-                <a:solidFill>
-                  <a:schemeClr val="accent6"/>
-                </a:solidFill>
-              </a:rPr>
-              <a:t>실습 시간</a:t>
-            </a:r>
-            <a:endParaRPr lang="en-US" sz="1200" dirty="0"/>
-          </a:p>
-        </p:txBody>
-      </p:sp>
-      <p:sp>
-        <p:nvSpPr>
-          <p:cNvPr id="25" name="Text 23"/>
-          <p:cNvSpPr txBox="1"/>
-          <p:nvPr/>
-        </p:nvSpPr>
-        <p:spPr>
-          <a:xfrm>
-            <a:off x="9601200" y="1847088"/>
-            <a:ext cx="2011680" cy="502920"/>
-          </a:xfrm>
-          <a:prstGeom prst="rect">
-            <a:avLst/>
-          </a:prstGeom>
-          <a:noFill/>
-          <a:ln/>
-        </p:spPr>
-        <p:txBody>
-          <a:bodyPr wrap="square" lIns="0" tIns="0" rIns="0" bIns="0" rtlCol="0" anchor="t"/>
-          <a:lstStyle/>
-          <a:p>
-            <a:pPr algn="ctr" indent="0" marL="0">
-              <a:buNone/>
-            </a:pPr>
-            <a:r>
-              <a:rPr lang="en-US" sz="2800" b="1" dirty="0">
-                <a:solidFill>
-                  <a:schemeClr val="bg1"/>
-                </a:solidFill>
-              </a:rPr>
-              <a:t>15분</a:t>
-            </a:r>
-            <a:endParaRPr lang="en-US" sz="2800" dirty="0"/>
-          </a:p>
-        </p:txBody>
-      </p:sp>
-      <p:sp>
-        <p:nvSpPr>
-          <p:cNvPr id="26" name="raise hand circle"/>
-          <p:cNvSpPr/>
-          <p:nvPr/>
-        </p:nvSpPr>
-        <p:spPr>
-          <a:xfrm>
-            <a:off x="10012680" y="2926080"/>
-            <a:ext cx="1188720" cy="1188720"/>
-          </a:xfrm>
-          <a:prstGeom prst="ellipse">
-            <a:avLst/>
-          </a:prstGeom>
-          <a:solidFill>
-            <a:schemeClr val="accent2"/>
+            <a:schemeClr val="accent4"/>
           </a:solidFill>
           <a:ln/>
         </p:spPr>
       </p:sp>
       <p:pic>
         <p:nvPicPr>
-          <p:cNvPr id="27" name="raise hand" descr="raise hand">    </p:cNvPr>
+          <p:cNvPr id="20" name="tip" descr="tip">    </p:cNvPr>
           <p:cNvPicPr>
             <a:picLocks noChangeAspect="1"/>
           </p:cNvPicPr>
@@ -4817,6 +4595,191 @@
         </p:blipFill>
         <p:spPr>
           <a:xfrm>
+            <a:off x="955548" y="5225796"/>
+            <a:ext cx="329184" cy="329184"/>
+          </a:xfrm>
+          <a:prstGeom prst="rect">
+            <a:avLst/>
+          </a:prstGeom>
+        </p:spPr>
+      </p:pic>
+      <p:sp>
+        <p:nvSpPr>
+          <p:cNvPr id="21" name="Text 18"/>
+          <p:cNvSpPr txBox="1"/>
+          <p:nvPr/>
+        </p:nvSpPr>
+        <p:spPr>
+          <a:xfrm>
+            <a:off x="1645920" y="4892040"/>
+            <a:ext cx="7223760" cy="1005840"/>
+          </a:xfrm>
+          <a:prstGeom prst="rect">
+            <a:avLst/>
+          </a:prstGeom>
+          <a:noFill/>
+          <a:ln/>
+        </p:spPr>
+        <p:txBody>
+          <a:bodyPr wrap="square" lIns="0" tIns="0" rIns="0" bIns="0" rtlCol="0" anchor="ctr"/>
+          <a:lstStyle/>
+          <a:p>
+            <a:pPr indent="0" marL="0">
+              <a:buNone/>
+            </a:pPr>
+            <a:r>
+              <a:rPr lang="en-US" sz="1500" b="1" dirty="0">
+                <a:solidFill>
+                  <a:schemeClr val="accent4"/>
+                </a:solidFill>
+              </a:rPr>
+              <a:t>막막하면?  </a:t>
+            </a:r>
+            <a:pPr indent="0" marL="0">
+              <a:buNone/>
+            </a:pPr>
+            <a:r>
+              <a:rPr lang="en-US" sz="1500" dirty="0">
+                <a:solidFill>
+                  <a:schemeClr val="bg1"/>
+                </a:solidFill>
+              </a:rPr>
+              <a:t>8번 화면의 예시 프롬프트에서 단어 2~3개만 내 것으로 바꿔도 충분해요</a:t>
+            </a:r>
+            <a:endParaRPr lang="en-US" sz="1500" dirty="0"/>
+          </a:p>
+        </p:txBody>
+      </p:sp>
+      <p:sp>
+        <p:nvSpPr>
+          <p:cNvPr id="22" name="timer"/>
+          <p:cNvSpPr/>
+          <p:nvPr/>
+        </p:nvSpPr>
+        <p:spPr>
+          <a:xfrm>
+            <a:off x="9601200" y="1463040"/>
+            <a:ext cx="2011680" cy="1005840"/>
+          </a:xfrm>
+          <a:prstGeom prst="roundRect">
+            <a:avLst>
+              <a:gd name="adj" fmla="val 12727"/>
+            </a:avLst>
+          </a:prstGeom>
+          <a:solidFill>
+            <a:schemeClr val="tx1"/>
+          </a:solidFill>
+          <a:ln/>
+        </p:spPr>
+      </p:sp>
+      <p:sp>
+        <p:nvSpPr>
+          <p:cNvPr id="23" name="Text 20"/>
+          <p:cNvSpPr txBox="1"/>
+          <p:nvPr/>
+        </p:nvSpPr>
+        <p:spPr>
+          <a:xfrm>
+            <a:off x="9601200" y="1572768"/>
+            <a:ext cx="2011680" cy="274320"/>
+          </a:xfrm>
+          <a:prstGeom prst="rect">
+            <a:avLst/>
+          </a:prstGeom>
+          <a:noFill/>
+          <a:ln/>
+        </p:spPr>
+        <p:txBody>
+          <a:bodyPr wrap="square" lIns="0" tIns="0" rIns="0" bIns="0" rtlCol="0" anchor="t"/>
+          <a:lstStyle/>
+          <a:p>
+            <a:pPr algn="ctr" indent="0" marL="0">
+              <a:buNone/>
+            </a:pPr>
+            <a:r>
+              <a:rPr lang="en-US" sz="1200" dirty="0">
+                <a:solidFill>
+                  <a:schemeClr val="accent6"/>
+                </a:solidFill>
+              </a:rPr>
+              <a:t>실습 시간</a:t>
+            </a:r>
+            <a:endParaRPr lang="en-US" sz="1200" dirty="0"/>
+          </a:p>
+        </p:txBody>
+      </p:sp>
+      <p:sp>
+        <p:nvSpPr>
+          <p:cNvPr id="24" name="Text 21"/>
+          <p:cNvSpPr txBox="1"/>
+          <p:nvPr/>
+        </p:nvSpPr>
+        <p:spPr>
+          <a:xfrm>
+            <a:off x="9601200" y="1847088"/>
+            <a:ext cx="2011680" cy="502920"/>
+          </a:xfrm>
+          <a:prstGeom prst="rect">
+            <a:avLst/>
+          </a:prstGeom>
+          <a:noFill/>
+          <a:ln/>
+        </p:spPr>
+        <p:txBody>
+          <a:bodyPr wrap="square" lIns="0" tIns="0" rIns="0" bIns="0" rtlCol="0" anchor="t"/>
+          <a:lstStyle/>
+          <a:p>
+            <a:pPr algn="ctr" indent="0" marL="0">
+              <a:buNone/>
+            </a:pPr>
+            <a:r>
+              <a:rPr lang="en-US" sz="2800" b="1" dirty="0">
+                <a:solidFill>
+                  <a:schemeClr val="bg1"/>
+                </a:solidFill>
+              </a:rPr>
+              <a:t>12분</a:t>
+            </a:r>
+            <a:endParaRPr lang="en-US" sz="2800" dirty="0"/>
+          </a:p>
+        </p:txBody>
+      </p:sp>
+      <p:sp>
+        <p:nvSpPr>
+          <p:cNvPr id="25" name="raise hand circle"/>
+          <p:cNvSpPr/>
+          <p:nvPr/>
+        </p:nvSpPr>
+        <p:spPr>
+          <a:xfrm>
+            <a:off x="10012680" y="2926080"/>
+            <a:ext cx="1188720" cy="1188720"/>
+          </a:xfrm>
+          <a:prstGeom prst="ellipse">
+            <a:avLst/>
+          </a:prstGeom>
+          <a:solidFill>
+            <a:schemeClr val="accent2"/>
+          </a:solidFill>
+          <a:ln/>
+        </p:spPr>
+      </p:sp>
+      <p:pic>
+        <p:nvPicPr>
+          <p:cNvPr id="26" name="raise hand" descr="raise hand">    </p:cNvPr>
+          <p:cNvPicPr>
+            <a:picLocks noChangeAspect="1"/>
+          </p:cNvPicPr>
+          <p:nvPr/>
+        </p:nvPicPr>
+        <p:blipFill>
+          <a:blip r:embed="rId2"/>
+          <a:stretch>
+            <a:fillRect/>
+          </a:stretch>
+        </p:blipFill>
+        <p:spPr>
+          <a:xfrm>
             <a:off x="10321747" y="3235147"/>
             <a:ext cx="570586" cy="570586"/>
           </a:xfrm>
@@ -4827,7 +4790,7 @@
       </p:pic>
       <p:sp>
         <p:nvSpPr>
-          <p:cNvPr id="28" name="Text 25"/>
+          <p:cNvPr id="27" name="Text 23"/>
           <p:cNvSpPr txBox="1"/>
           <p:nvPr/>
         </p:nvSpPr>
@@ -4855,7 +4818,7 @@
                   <a:schemeClr val="tx2"/>
                 </a:solidFill>
               </a:rPr>
-              <a:t>STEP 3까지 끝나면</a:t>
+              <a:t>다 쓰면 바로</a:t>
             </a:r>
             <a:endParaRPr lang="en-US" sz="1400" dirty="0"/>
           </a:p>
@@ -4869,7 +4832,7 @@
                   <a:schemeClr val="tx2"/>
                 </a:solidFill>
               </a:rPr>
-              <a:t>손을 들어 주세요!</a:t>
+              <a:t>AI 노래 만들기로!</a:t>
             </a:r>
             <a:endParaRPr lang="en-US" sz="1400" dirty="0"/>
           </a:p>
@@ -4977,7 +4940,7 @@
                   <a:schemeClr val="tx1"/>
                 </a:solidFill>
               </a:rPr>
-              <a:t>AI 노래 발표회</a:t>
+              <a:t>실습 · 내 휴대폰으로 AI 노래 만들기</a:t>
             </a:r>
             <a:endParaRPr lang="en-US" sz="3200" dirty="0"/>
           </a:p>
@@ -5035,7 +4998,7 @@
                   <a:schemeClr val="accent1"/>
                 </a:solidFill>
               </a:rPr>
-              <a:t>이렇게 진행해요</a:t>
+              <a:t>15분 동안 해요</a:t>
             </a:r>
             <a:endParaRPr lang="en-US" sz="1900" dirty="0"/>
           </a:p>
@@ -5050,7 +5013,7 @@
         <p:spPr>
           <a:xfrm>
             <a:off x="868680" y="2240280"/>
-            <a:ext cx="4937760" cy="3291840"/>
+            <a:ext cx="4937760" cy="3474720"/>
           </a:xfrm>
           <a:prstGeom prst="rect">
             <a:avLst/>
@@ -5064,7 +5027,7 @@
           <a:p>
             <a:pPr marL="342900" indent="-342900">
               <a:spcAft>
-                <a:spcPts val="1400"/>
+                <a:spcPts val="1000"/>
               </a:spcAft>
               <a:buSzPct val="100000"/>
               <a:buFont typeface="+mj-lt"/>
@@ -5076,14 +5039,14 @@
                   <a:schemeClr val="tx1"/>
                 </a:solidFill>
               </a:rPr>
-              <a:t>프롬프터가 프롬프트와 가사를 읽어 줘요</a:t>
+              <a:t>QR로 AI 음악 사이트 접속 (가입 X)</a:t>
             </a:r>
             <a:endParaRPr lang="en-US" sz="1600" dirty="0"/>
           </a:p>
           <a:p>
             <a:pPr marL="342900" indent="-342900">
               <a:spcAft>
-                <a:spcPts val="1400"/>
+                <a:spcPts val="1000"/>
               </a:spcAft>
               <a:buSzPct val="100000"/>
               <a:buFont typeface="+mj-lt"/>
@@ -5095,14 +5058,14 @@
                   <a:schemeClr val="tx1"/>
                 </a:solidFill>
               </a:rPr>
-              <a:t>선생님이 화면에서 바로 노래를 생성해요 (1~2분)</a:t>
+              <a:t>프롬프트(+가사) 입력하고 만들기</a:t>
             </a:r>
             <a:endParaRPr lang="en-US" sz="1600" dirty="0"/>
           </a:p>
           <a:p>
             <a:pPr marL="342900" indent="-342900">
               <a:spcAft>
-                <a:spcPts val="1400"/>
+                <a:spcPts val="1000"/>
               </a:spcAft>
               <a:buSzPct val="100000"/>
               <a:buFont typeface="+mj-lt"/>
@@ -5114,14 +5077,14 @@
                   <a:schemeClr val="tx1"/>
                 </a:solidFill>
               </a:rPr>
-              <a:t>두 곡을 듣고 모둠이 한 곡을 골라요</a:t>
+              <a:t>기다리는 동안 활동지 4컷 스토리보드 그리기</a:t>
             </a:r>
             <a:endParaRPr lang="en-US" sz="1600" dirty="0"/>
           </a:p>
           <a:p>
             <a:pPr marL="342900" indent="-342900">
               <a:spcAft>
-                <a:spcPts val="1400"/>
+                <a:spcPts val="1000"/>
               </a:spcAft>
               <a:buSzPct val="100000"/>
               <a:buFont typeface="+mj-lt"/>
@@ -5133,7 +5096,26 @@
                   <a:schemeClr val="tx1"/>
                 </a:solidFill>
               </a:rPr>
-              <a:t>다른 모둠은 박수로 응원해요</a:t>
+              <a:t>마음에 드는 곡을 MP3로 다운로드</a:t>
+            </a:r>
+            <a:endParaRPr lang="en-US" sz="1600" dirty="0"/>
+          </a:p>
+          <a:p>
+            <a:pPr marL="342900" indent="-342900">
+              <a:spcAft>
+                <a:spcPts val="1000"/>
+              </a:spcAft>
+              <a:buSzPct val="100000"/>
+              <a:buFont typeface="+mj-lt"/>
+              <a:buAutoNum type="arabicPeriod" startAt="1"/>
+            </a:pPr>
+            <a:r>
+              <a:rPr lang="en-US" sz="1600" b="1" dirty="0">
+                <a:solidFill>
+                  <a:schemeClr val="accent2"/>
+                </a:solidFill>
+              </a:rPr>
+              <a:t>안 되면? 패들렛 예비 음원에서 고르기</a:t>
             </a:r>
             <a:endParaRPr lang="en-US" sz="1600" dirty="0"/>
           </a:p>
@@ -5275,7 +5257,7 @@
                   <a:schemeClr val="bg1"/>
                 </a:solidFill>
               </a:rPr>
-              <a:t>우리가 쓴 프롬프트대로 나왔나요?</a:t>
+              <a:t>내가 쓴 프롬프트대로 나왔나요?</a:t>
             </a:r>
             <a:endParaRPr lang="en-US" sz="1600" dirty="0"/>
           </a:p>
@@ -5795,7 +5777,7 @@
                   <a:schemeClr val="tx1"/>
                 </a:solidFill>
               </a:rPr>
-              <a:t>패들렛에서 노래 파일 받기</a:t>
+              <a:t>내가 받은 노래 파일 찾기</a:t>
             </a:r>
             <a:endParaRPr lang="en-US" sz="3200" dirty="0"/>
           </a:p>
@@ -5938,7 +5920,7 @@
                   <a:schemeClr val="tx1"/>
                 </a:solidFill>
               </a:rPr>
-              <a:t>카메라로 칠판의 QR 찍기</a:t>
+              <a:t>'내 파일' 앱 열기</a:t>
             </a:r>
             <a:endParaRPr lang="en-US" sz="1600" dirty="0"/>
           </a:p>
@@ -5957,7 +5939,7 @@
                   <a:schemeClr val="tx1"/>
                 </a:solidFill>
               </a:rPr>
-              <a:t>우리 모둠 노래 → 다운로드</a:t>
+              <a:t>'다운로드' 폴더 확인</a:t>
             </a:r>
             <a:endParaRPr lang="en-US" sz="1600" dirty="0"/>
           </a:p>
@@ -5976,7 +5958,7 @@
                   <a:schemeClr val="tx1"/>
                 </a:solidFill>
               </a:rPr>
-              <a:t>'내 파일 → 다운로드' 폴더에 저장돼요</a:t>
+              <a:t>노래가 재생되는지 들어 보기</a:t>
             </a:r>
             <a:endParaRPr lang="en-US" sz="1600" dirty="0"/>
           </a:p>
@@ -6119,7 +6101,7 @@
                   <a:schemeClr val="tx1"/>
                 </a:solidFill>
               </a:rPr>
-              <a:t>카메라로 칠판의 QR 찍기</a:t>
+              <a:t>다운로드할 때 '파일에 저장' 선택</a:t>
             </a:r>
             <a:endParaRPr lang="en-US" sz="1600" dirty="0"/>
           </a:p>
@@ -6138,7 +6120,7 @@
                   <a:schemeClr val="tx1"/>
                 </a:solidFill>
               </a:rPr>
-              <a:t>노래 → 공유 버튼 → '파일에 저장'</a:t>
+              <a:t>'파일' 앱 → '다운로드' 확인</a:t>
             </a:r>
             <a:endParaRPr lang="en-US" sz="1600" dirty="0"/>
           </a:p>
@@ -6157,7 +6139,7 @@
                   <a:schemeClr val="tx1"/>
                 </a:solidFill>
               </a:rPr>
-              <a:t>'파일' 앱에 저장돼요</a:t>
+              <a:t>노래가 재생되는지 들어 보기</a:t>
             </a:r>
             <a:endParaRPr lang="en-US" sz="1600" dirty="0"/>
           </a:p>
@@ -7582,7 +7564,7 @@
                   <a:schemeClr val="tx2"/>
                 </a:solidFill>
               </a:rPr>
-              <a:t>오디오 → 사운드 → 기기에서 우리 모둠 노래</a:t>
+              <a:t>오디오 → 사운드 → 기기에서 내 노래</a:t>
             </a:r>
             <a:endParaRPr lang="en-US" sz="1400" dirty="0"/>
           </a:p>
@@ -9903,7 +9885,7 @@
                   <a:schemeClr val="tx1"/>
                 </a:solidFill>
               </a:rPr>
-              <a:t>상영회 &amp; 피드백</a:t>
+              <a:t>짝 감상 &amp; 상영회</a:t>
             </a:r>
             <a:endParaRPr lang="en-US" sz="3200" dirty="0"/>
           </a:p>
@@ -10171,7 +10153,7 @@
                   <a:schemeClr val="tx2"/>
                 </a:solidFill>
               </a:rPr>
-              <a:t>우리 모둠만의 아이디어가 보이나요?</a:t>
+              <a:t>나만의 아이디어가 보이나요?</a:t>
             </a:r>
             <a:endParaRPr lang="en-US" sz="1500" dirty="0"/>
           </a:p>
@@ -10728,7 +10710,7 @@
                   <a:schemeClr val="tx2"/>
                 </a:solidFill>
               </a:rPr>
-              <a:t>AI로 우리 모둠</a:t>
+              <a:t>AI로 나만의</a:t>
             </a:r>
             <a:endParaRPr lang="en-US" sz="1400" dirty="0"/>
           </a:p>
@@ -10908,7 +10890,7 @@
                   <a:schemeClr val="tx2"/>
                 </a:solidFill>
               </a:rPr>
-              <a:t>받아 두기</a:t>
+              <a:t>저장 확인</a:t>
             </a:r>
             <a:endParaRPr lang="en-US" sz="1400" dirty="0"/>
           </a:p>
@@ -11353,7 +11335,7 @@
                   <a:schemeClr val="tx1"/>
                 </a:solidFill>
               </a:rPr>
-              <a:t>우리 모둠이 만든 노래 + 직접 찍은 영상 = 30초~1분 뮤직비디오</a:t>
+              <a:t>내가 만든 노래 + 내가 찍은 영상 = 30초~1분 나만의 뮤직비디오</a:t>
             </a:r>
             <a:endParaRPr lang="en-US" sz="1800" dirty="0"/>
           </a:p>
@@ -12368,7 +12350,7 @@
                   <a:schemeClr val="tx2"/>
                 </a:solidFill>
               </a:rPr>
-              <a:t>모둠별로</a:t>
+              <a:t>한 명에</a:t>
             </a:r>
             <a:endParaRPr lang="en-US" sz="1400" dirty="0"/>
           </a:p>
@@ -12382,7 +12364,7 @@
                   <a:schemeClr val="tx2"/>
                 </a:solidFill>
               </a:rPr>
-              <a:t>활동지 받기</a:t>
+              <a:t>한 장씩</a:t>
             </a:r>
             <a:endParaRPr lang="en-US" sz="1400" dirty="0"/>
           </a:p>
@@ -12484,7 +12466,7 @@
                   <a:schemeClr val="accent4"/>
                 </a:solidFill>
               </a:rPr>
-              <a:t>AI 사이트에 가입하지 않아요!  </a:t>
+              <a:t>회원가입 없이 써요!  </a:t>
             </a:r>
             <a:pPr indent="0" marL="0">
               <a:buNone/>
@@ -12495,7 +12477,7 @@
                   <a:schemeClr val="bg1"/>
                 </a:solidFill>
               </a:rPr>
-              <a:t>AI 생성은 선생님 계정으로 화면에서 함께 해요</a:t>
+              <a:t>선생님이 알려 주는 가입 없는 AI 음악 사이트만 사용해요</a:t>
             </a:r>
             <a:endParaRPr lang="en-US" sz="1800" dirty="0"/>
           </a:p>
@@ -13406,7 +13388,7 @@
                   <a:schemeClr val="tx1"/>
                 </a:solidFill>
               </a:rPr>
-              <a:t>우리 모둠 역할 정하기</a:t>
+              <a:t>오늘 나 혼자 완성하는 5단계</a:t>
             </a:r>
             <a:endParaRPr lang="en-US" sz="3200" dirty="0"/>
           </a:p>
@@ -13414,7 +13396,7 @@
       </p:sp>
       <p:sp>
         <p:nvSpPr>
-          <p:cNvPr id="3" name="작사가"/>
+          <p:cNvPr id="3" name="① 기획"/>
           <p:cNvSpPr/>
           <p:nvPr/>
         </p:nvSpPr>
@@ -13436,7 +13418,7 @@
       </p:sp>
       <p:sp>
         <p:nvSpPr>
-          <p:cNvPr id="4" name="작사가 circle"/>
+          <p:cNvPr id="4" name="① 기획 circle"/>
           <p:cNvSpPr/>
           <p:nvPr/>
         </p:nvSpPr>
@@ -13456,7 +13438,7 @@
       </p:sp>
       <p:pic>
         <p:nvPicPr>
-          <p:cNvPr id="5" name="작사가" descr="작사가">    </p:cNvPr>
+          <p:cNvPr id="5" name="① 기획" descr="① 기획">    </p:cNvPr>
           <p:cNvPicPr>
             <a:picLocks noChangeAspect="1"/>
           </p:cNvPicPr>
@@ -13508,7 +13490,7 @@
                   <a:schemeClr val="tx1"/>
                 </a:solidFill>
               </a:rPr>
-              <a:t>작사가</a:t>
+              <a:t>① 기획</a:t>
             </a:r>
             <a:endParaRPr lang="en-US" sz="1900" dirty="0"/>
           </a:p>
@@ -13544,7 +13526,7 @@
                   <a:schemeClr val="tx2"/>
                 </a:solidFill>
               </a:rPr>
-              <a:t>가사 8줄을</a:t>
+              <a:t>주제·프롬프트</a:t>
             </a:r>
             <a:endParaRPr lang="en-US" sz="1400" dirty="0"/>
           </a:p>
@@ -13558,7 +13540,7 @@
                   <a:schemeClr val="tx2"/>
                 </a:solidFill>
               </a:rPr>
-              <a:t>정리해요</a:t>
+              <a:t>가사 쓰기</a:t>
             </a:r>
             <a:endParaRPr lang="en-US" sz="1400" dirty="0"/>
           </a:p>
@@ -13566,7 +13548,7 @@
       </p:sp>
       <p:sp>
         <p:nvSpPr>
-          <p:cNvPr id="8" name="프롬프터"/>
+          <p:cNvPr id="8" name="② AI 노래"/>
           <p:cNvSpPr/>
           <p:nvPr/>
         </p:nvSpPr>
@@ -13588,7 +13570,7 @@
       </p:sp>
       <p:sp>
         <p:nvSpPr>
-          <p:cNvPr id="9" name="프롬프터 circle"/>
+          <p:cNvPr id="9" name="② AI 노래 circle"/>
           <p:cNvSpPr/>
           <p:nvPr/>
         </p:nvSpPr>
@@ -13608,7 +13590,7 @@
       </p:sp>
       <p:pic>
         <p:nvPicPr>
-          <p:cNvPr id="10" name="프롬프터" descr="프롬프터">    </p:cNvPr>
+          <p:cNvPr id="10" name="② AI 노래" descr="② AI 노래">    </p:cNvPr>
           <p:cNvPicPr>
             <a:picLocks noChangeAspect="1"/>
           </p:cNvPicPr>
@@ -13660,7 +13642,7 @@
                   <a:schemeClr val="tx1"/>
                 </a:solidFill>
               </a:rPr>
-              <a:t>프롬프터</a:t>
+              <a:t>② AI 노래</a:t>
             </a:r>
             <a:endParaRPr lang="en-US" sz="1900" dirty="0"/>
           </a:p>
@@ -13696,7 +13678,7 @@
                   <a:schemeClr val="tx2"/>
                 </a:solidFill>
               </a:rPr>
-              <a:t>음악·이미지</a:t>
+              <a:t>내 휴대폰으로</a:t>
             </a:r>
             <a:endParaRPr lang="en-US" sz="1400" dirty="0"/>
           </a:p>
@@ -13710,7 +13692,7 @@
                   <a:schemeClr val="tx2"/>
                 </a:solidFill>
               </a:rPr>
-              <a:t>프롬프트 완성</a:t>
+              <a:t>노래 만들기</a:t>
             </a:r>
             <a:endParaRPr lang="en-US" sz="1400" dirty="0"/>
           </a:p>
@@ -13718,7 +13700,7 @@
       </p:sp>
       <p:sp>
         <p:nvSpPr>
-          <p:cNvPr id="13" name="감독"/>
+          <p:cNvPr id="13" name="③ 촬영"/>
           <p:cNvSpPr/>
           <p:nvPr/>
         </p:nvSpPr>
@@ -13740,7 +13722,7 @@
       </p:sp>
       <p:sp>
         <p:nvSpPr>
-          <p:cNvPr id="14" name="감독 circle"/>
+          <p:cNvPr id="14" name="③ 촬영 circle"/>
           <p:cNvSpPr/>
           <p:nvPr/>
         </p:nvSpPr>
@@ -13760,7 +13742,7 @@
       </p:sp>
       <p:pic>
         <p:nvPicPr>
-          <p:cNvPr id="15" name="감독" descr="감독">    </p:cNvPr>
+          <p:cNvPr id="15" name="③ 촬영" descr="③ 촬영">    </p:cNvPr>
           <p:cNvPicPr>
             <a:picLocks noChangeAspect="1"/>
           </p:cNvPicPr>
@@ -13812,7 +13794,7 @@
                   <a:schemeClr val="tx1"/>
                 </a:solidFill>
               </a:rPr>
-              <a:t>감독</a:t>
+              <a:t>③ 촬영</a:t>
             </a:r>
             <a:endParaRPr lang="en-US" sz="1900" dirty="0"/>
           </a:p>
@@ -13848,7 +13830,7 @@
                   <a:schemeClr val="tx2"/>
                 </a:solidFill>
               </a:rPr>
-              <a:t>스토리보드와</a:t>
+              <a:t>스토리보드대로</a:t>
             </a:r>
             <a:endParaRPr lang="en-US" sz="1400" dirty="0"/>
           </a:p>
@@ -13862,7 +13844,7 @@
                   <a:schemeClr val="tx2"/>
                 </a:solidFill>
               </a:rPr>
-              <a:t>촬영을 이끌어요</a:t>
+              <a:t>4~6컷 찍기</a:t>
             </a:r>
             <a:endParaRPr lang="en-US" sz="1400" dirty="0"/>
           </a:p>
@@ -13870,7 +13852,7 @@
       </p:sp>
       <p:sp>
         <p:nvSpPr>
-          <p:cNvPr id="18" name="편집자"/>
+          <p:cNvPr id="18" name="④ 편집"/>
           <p:cNvSpPr/>
           <p:nvPr/>
         </p:nvSpPr>
@@ -13892,7 +13874,7 @@
       </p:sp>
       <p:sp>
         <p:nvSpPr>
-          <p:cNvPr id="19" name="편집자 circle"/>
+          <p:cNvPr id="19" name="④ 편집 circle"/>
           <p:cNvSpPr/>
           <p:nvPr/>
         </p:nvSpPr>
@@ -13912,7 +13894,7 @@
       </p:sp>
       <p:pic>
         <p:nvPicPr>
-          <p:cNvPr id="20" name="편집자" descr="편집자">    </p:cNvPr>
+          <p:cNvPr id="20" name="④ 편집" descr="④ 편집">    </p:cNvPr>
           <p:cNvPicPr>
             <a:picLocks noChangeAspect="1"/>
           </p:cNvPicPr>
@@ -13964,7 +13946,7 @@
                   <a:schemeClr val="tx1"/>
                 </a:solidFill>
               </a:rPr>
-              <a:t>편집자</a:t>
+              <a:t>④ 편집</a:t>
             </a:r>
             <a:endParaRPr lang="en-US" sz="1900" dirty="0"/>
           </a:p>
@@ -14014,7 +13996,7 @@
                   <a:schemeClr val="tx2"/>
                 </a:solidFill>
               </a:rPr>
-              <a:t>영상 편집</a:t>
+              <a:t>뮤직비디오</a:t>
             </a:r>
             <a:endParaRPr lang="en-US" sz="1400" dirty="0"/>
           </a:p>
@@ -14022,7 +14004,7 @@
       </p:sp>
       <p:sp>
         <p:nvSpPr>
-          <p:cNvPr id="23" name="발표자"/>
+          <p:cNvPr id="23" name="⑤ 공유"/>
           <p:cNvSpPr/>
           <p:nvPr/>
         </p:nvSpPr>
@@ -14044,7 +14026,7 @@
       </p:sp>
       <p:sp>
         <p:nvSpPr>
-          <p:cNvPr id="24" name="발표자 circle"/>
+          <p:cNvPr id="24" name="⑤ 공유 circle"/>
           <p:cNvSpPr/>
           <p:nvPr/>
         </p:nvSpPr>
@@ -14064,7 +14046,7 @@
       </p:sp>
       <p:pic>
         <p:nvPicPr>
-          <p:cNvPr id="25" name="발표자" descr="발표자">    </p:cNvPr>
+          <p:cNvPr id="25" name="⑤ 공유" descr="⑤ 공유">    </p:cNvPr>
           <p:cNvPicPr>
             <a:picLocks noChangeAspect="1"/>
           </p:cNvPicPr>
@@ -14116,7 +14098,7 @@
                   <a:schemeClr val="tx1"/>
                 </a:solidFill>
               </a:rPr>
-              <a:t>발표자</a:t>
+              <a:t>⑤ 공유</a:t>
             </a:r>
             <a:endParaRPr lang="en-US" sz="1900" dirty="0"/>
           </a:p>
@@ -14152,7 +14134,7 @@
                   <a:schemeClr val="tx2"/>
                 </a:solidFill>
               </a:rPr>
-              <a:t>상영회에서</a:t>
+              <a:t>패들렛에 올리고</a:t>
             </a:r>
             <a:endParaRPr lang="en-US" sz="1400" dirty="0"/>
           </a:p>
@@ -14166,7 +14148,7 @@
                   <a:schemeClr val="tx2"/>
                 </a:solidFill>
               </a:rPr>
-              <a:t>작품 소개</a:t>
+              <a:t>짝과 감상</a:t>
             </a:r>
             <a:endParaRPr lang="en-US" sz="1400" dirty="0"/>
           </a:p>
@@ -14202,7 +14184,7 @@
                   <a:schemeClr val="accent2"/>
                 </a:solidFill>
               </a:rPr>
-              <a:t>모둠 4~5명  </a:t>
+              <a:t>모두가 감독  </a:t>
             </a:r>
             <a:pPr indent="0" marL="0">
               <a:buNone/>
@@ -14213,7 +14195,7 @@
                   <a:schemeClr val="tx1"/>
                 </a:solidFill>
               </a:rPr>
-              <a:t>4명 모둠은 발표자를 감독이 함께 맡아요. 활동지 맨 위 표에 이름을 적어요.</a:t>
+              <a:t>작사, 작곡(AI), 촬영, 편집까지 오늘은 나 혼자 다 해요. 막히면 옆 친구와 도와도 OK!</a:t>
             </a:r>
             <a:endParaRPr lang="en-US" sz="1600" dirty="0"/>
           </a:p>
@@ -14357,7 +14339,7 @@
                   <a:schemeClr val="bg1"/>
                 </a:solidFill>
               </a:rPr>
-              <a:t>AI로 우리 모둠 노래 만들기</a:t>
+              <a:t>AI로 나만의 노래 만들기</a:t>
             </a:r>
             <a:endParaRPr lang="en-US" sz="4000" dirty="0"/>
           </a:p>
@@ -14395,7 +14377,7 @@
                   <a:schemeClr val="accent6"/>
                 </a:solidFill>
               </a:rPr>
-              <a:t>가사 8줄로 노래 한 곡 완성하기</a:t>
+              <a:t>내 휴대폰으로 노래 한 곡 완성하기</a:t>
             </a:r>
             <a:endParaRPr lang="en-US" sz="2000" dirty="0"/>
           </a:p>
@@ -14687,7 +14669,7 @@
       </p:sp>
       <p:sp>
         <p:nvSpPr>
-          <p:cNvPr id="3" name="모둠이 기획"/>
+          <p:cNvPr id="3" name="QR로 접속"/>
           <p:cNvSpPr/>
           <p:nvPr/>
         </p:nvSpPr>
@@ -14721,7 +14703,7 @@
       </p:sp>
       <p:sp>
         <p:nvSpPr>
-          <p:cNvPr id="4" name="모둠이 기획 circle"/>
+          <p:cNvPr id="4" name="QR로 접속 circle"/>
           <p:cNvSpPr/>
           <p:nvPr/>
         </p:nvSpPr>
@@ -14741,7 +14723,7 @@
       </p:sp>
       <p:pic>
         <p:nvPicPr>
-          <p:cNvPr id="5" name="모둠이 기획" descr="모둠이 기획">    </p:cNvPr>
+          <p:cNvPr id="5" name="QR로 접속" descr="QR로 접속">    </p:cNvPr>
           <p:cNvPicPr>
             <a:picLocks noChangeAspect="1"/>
           </p:cNvPicPr>
@@ -14829,7 +14811,7 @@
                   <a:schemeClr val="tx1"/>
                 </a:solidFill>
               </a:rPr>
-              <a:t>모둠이 기획</a:t>
+              <a:t>QR로 접속</a:t>
             </a:r>
             <a:endParaRPr lang="en-US" sz="1900" dirty="0"/>
           </a:p>
@@ -14865,7 +14847,7 @@
                   <a:schemeClr val="tx2"/>
                 </a:solidFill>
               </a:rPr>
-              <a:t>활동지에 프롬프트와</a:t>
+              <a:t>칠판 QR을 찍어</a:t>
             </a:r>
             <a:endParaRPr lang="en-US" sz="1400" dirty="0"/>
           </a:p>
@@ -14879,7 +14861,7 @@
                   <a:schemeClr val="tx2"/>
                 </a:solidFill>
               </a:rPr>
-              <a:t>가사 8줄 쓰기</a:t>
+              <a:t>AI 음악 사이트 열기</a:t>
             </a:r>
             <a:endParaRPr lang="en-US" sz="1400" dirty="0"/>
           </a:p>
@@ -14907,7 +14889,7 @@
       </p:sp>
       <p:sp>
         <p:nvSpPr>
-          <p:cNvPr id="10" name="선생님이 생성"/>
+          <p:cNvPr id="10" name="프롬프트 입력"/>
           <p:cNvSpPr/>
           <p:nvPr/>
         </p:nvSpPr>
@@ -14941,7 +14923,7 @@
       </p:sp>
       <p:sp>
         <p:nvSpPr>
-          <p:cNvPr id="11" name="선생님이 생성 circle"/>
+          <p:cNvPr id="11" name="프롬프트 입력 circle"/>
           <p:cNvSpPr/>
           <p:nvPr/>
         </p:nvSpPr>
@@ -14961,7 +14943,7 @@
       </p:sp>
       <p:pic>
         <p:nvPicPr>
-          <p:cNvPr id="12" name="선생님이 생성" descr="선생님이 생성">    </p:cNvPr>
+          <p:cNvPr id="12" name="프롬프트 입력" descr="프롬프트 입력">    </p:cNvPr>
           <p:cNvPicPr>
             <a:picLocks noChangeAspect="1"/>
           </p:cNvPicPr>
@@ -15049,7 +15031,7 @@
                   <a:schemeClr val="tx1"/>
                 </a:solidFill>
               </a:rPr>
-              <a:t>선생님이 생성</a:t>
+              <a:t>프롬프트 입력</a:t>
             </a:r>
             <a:endParaRPr lang="en-US" sz="1900" dirty="0"/>
           </a:p>
@@ -15085,7 +15067,7 @@
                   <a:schemeClr val="tx2"/>
                 </a:solidFill>
               </a:rPr>
-              <a:t>AI 음악 도구 Suno로</a:t>
+              <a:t>활동지에 쓴 프롬프트</a:t>
             </a:r>
             <a:endParaRPr lang="en-US" sz="1400" dirty="0"/>
           </a:p>
@@ -15099,7 +15081,7 @@
                   <a:schemeClr val="tx2"/>
                 </a:solidFill>
               </a:rPr>
-              <a:t>화면에서 바로 생성</a:t>
+              <a:t>(+가사) 입력</a:t>
             </a:r>
             <a:endParaRPr lang="en-US" sz="1400" dirty="0"/>
           </a:p>
@@ -15127,7 +15109,7 @@
       </p:sp>
       <p:sp>
         <p:nvSpPr>
-          <p:cNvPr id="17" name="다 함께 감상"/>
+          <p:cNvPr id="17" name="만들고 비교"/>
           <p:cNvSpPr/>
           <p:nvPr/>
         </p:nvSpPr>
@@ -15161,7 +15143,7 @@
       </p:sp>
       <p:sp>
         <p:nvSpPr>
-          <p:cNvPr id="18" name="다 함께 감상 circle"/>
+          <p:cNvPr id="18" name="만들고 비교 circle"/>
           <p:cNvSpPr/>
           <p:nvPr/>
         </p:nvSpPr>
@@ -15181,7 +15163,7 @@
       </p:sp>
       <p:pic>
         <p:nvPicPr>
-          <p:cNvPr id="19" name="다 함께 감상" descr="다 함께 감상">    </p:cNvPr>
+          <p:cNvPr id="19" name="만들고 비교" descr="만들고 비교">    </p:cNvPr>
           <p:cNvPicPr>
             <a:picLocks noChangeAspect="1"/>
           </p:cNvPicPr>
@@ -15269,7 +15251,7 @@
                   <a:schemeClr val="tx1"/>
                 </a:solidFill>
               </a:rPr>
-              <a:t>다 함께 감상</a:t>
+              <a:t>만들고 비교</a:t>
             </a:r>
             <a:endParaRPr lang="en-US" sz="1900" dirty="0"/>
           </a:p>
@@ -15305,7 +15287,7 @@
                   <a:schemeClr val="tx2"/>
                 </a:solidFill>
               </a:rPr>
-              <a:t>두 곡 중 마음에 드는</a:t>
+              <a:t>2번 이상 만들어 보고</a:t>
             </a:r>
             <a:endParaRPr lang="en-US" sz="1400" dirty="0"/>
           </a:p>
@@ -15319,7 +15301,7 @@
                   <a:schemeClr val="tx2"/>
                 </a:solidFill>
               </a:rPr>
-              <a:t>한 곡을 골라요</a:t>
+              <a:t>마음에 드는 곡 고르기</a:t>
             </a:r>
             <a:endParaRPr lang="en-US" sz="1400" dirty="0"/>
           </a:p>
@@ -15347,7 +15329,7 @@
       </p:sp>
       <p:sp>
         <p:nvSpPr>
-          <p:cNvPr id="24" name="패들렛으로 받기"/>
+          <p:cNvPr id="24" name="MP3 저장"/>
           <p:cNvSpPr/>
           <p:nvPr/>
         </p:nvSpPr>
@@ -15381,7 +15363,7 @@
       </p:sp>
       <p:sp>
         <p:nvSpPr>
-          <p:cNvPr id="25" name="패들렛으로 받기 circle"/>
+          <p:cNvPr id="25" name="MP3 저장 circle"/>
           <p:cNvSpPr/>
           <p:nvPr/>
         </p:nvSpPr>
@@ -15401,7 +15383,7 @@
       </p:sp>
       <p:pic>
         <p:nvPicPr>
-          <p:cNvPr id="26" name="패들렛으로 받기" descr="패들렛으로 받기">    </p:cNvPr>
+          <p:cNvPr id="26" name="MP3 저장" descr="MP3 저장">    </p:cNvPr>
           <p:cNvPicPr>
             <a:picLocks noChangeAspect="1"/>
           </p:cNvPicPr>
@@ -15489,7 +15471,7 @@
                   <a:schemeClr val="tx1"/>
                 </a:solidFill>
               </a:rPr>
-              <a:t>패들렛으로 받기</a:t>
+              <a:t>MP3 저장</a:t>
             </a:r>
             <a:endParaRPr lang="en-US" sz="1900" dirty="0"/>
           </a:p>
@@ -15525,7 +15507,7 @@
                   <a:schemeClr val="tx2"/>
                 </a:solidFill>
               </a:rPr>
-              <a:t>QR을 찍어 노래 파일을</a:t>
+              <a:t>다운로드 버튼으로</a:t>
             </a:r>
             <a:endParaRPr lang="en-US" sz="1400" dirty="0"/>
           </a:p>
@@ -15575,7 +15557,7 @@
                   <a:schemeClr val="tx2"/>
                 </a:solidFill>
               </a:rPr>
-              <a:t>※ 오늘 만든 노래는 개인 감상용이에요. 판매하거나 수익 채널에 올리면 안 돼요 (무료 플랜 약관)</a:t>
+              <a:t>※ 회원가입·결제 창이 뜨면 누르지 말고 손을 들어요. 오늘 만든 노래는 개인 감상용이에요</a:t>
             </a:r>
             <a:endParaRPr lang="en-US" sz="1300" dirty="0"/>
           </a:p>

</xml_diff>